<commit_message>
Fix formatting and animations
</commit_message>
<xml_diff>
--- a/containers_for_hpc.pptx
+++ b/containers_for_hpc.pptx
@@ -402,7 +402,7 @@
           <a:p>
             <a:fld id="{6BD974B4-F374-4E74-84D3-1EB7DBF32A2A}" type="datetimeFigureOut">
               <a:rPr lang="nl-BE" smtClean="0"/>
-              <a:t>11/08/2025</a:t>
+              <a:t>8/10/2025</a:t>
             </a:fld>
             <a:endParaRPr lang="nl-BE"/>
           </a:p>
@@ -885,7 +885,7 @@
           <a:p>
             <a:fld id="{A433E747-842D-4EF3-8202-AC54FEC33061}" type="datetime1">
               <a:rPr lang="nl-BE" smtClean="0"/>
-              <a:t>11/08/2025</a:t>
+              <a:t>8/10/2025</a:t>
             </a:fld>
             <a:endParaRPr lang="nl-BE"/>
           </a:p>
@@ -1055,7 +1055,7 @@
           <a:p>
             <a:fld id="{7C821354-3381-4DF5-ABED-FDAFA2BAD3F8}" type="datetime1">
               <a:rPr lang="nl-BE" smtClean="0"/>
-              <a:t>11/08/2025</a:t>
+              <a:t>8/10/2025</a:t>
             </a:fld>
             <a:endParaRPr lang="nl-BE"/>
           </a:p>
@@ -1235,7 +1235,7 @@
           <a:p>
             <a:fld id="{C6B54B95-9964-4BBF-B171-A69413AB9FC5}" type="datetime1">
               <a:rPr lang="nl-BE" smtClean="0"/>
-              <a:t>11/08/2025</a:t>
+              <a:t>8/10/2025</a:t>
             </a:fld>
             <a:endParaRPr lang="nl-BE"/>
           </a:p>
@@ -1405,7 +1405,7 @@
           <a:p>
             <a:fld id="{BE45CDE5-064C-4862-90E9-83B8FD778625}" type="datetime1">
               <a:rPr lang="nl-BE" smtClean="0"/>
-              <a:t>11/08/2025</a:t>
+              <a:t>8/10/2025</a:t>
             </a:fld>
             <a:endParaRPr lang="nl-BE"/>
           </a:p>
@@ -1649,7 +1649,7 @@
           <a:p>
             <a:fld id="{C75A345C-628E-463E-B8F7-69C25D344DF5}" type="datetime1">
               <a:rPr lang="nl-BE" smtClean="0"/>
-              <a:t>11/08/2025</a:t>
+              <a:t>8/10/2025</a:t>
             </a:fld>
             <a:endParaRPr lang="nl-BE"/>
           </a:p>
@@ -1881,7 +1881,7 @@
           <a:p>
             <a:fld id="{65B04534-538C-4249-A635-8BB2B8486464}" type="datetime1">
               <a:rPr lang="nl-BE" smtClean="0"/>
-              <a:t>11/08/2025</a:t>
+              <a:t>8/10/2025</a:t>
             </a:fld>
             <a:endParaRPr lang="nl-BE"/>
           </a:p>
@@ -2248,7 +2248,7 @@
           <a:p>
             <a:fld id="{089671CB-8547-4C91-A3D5-012E6E8790E6}" type="datetime1">
               <a:rPr lang="nl-BE" smtClean="0"/>
-              <a:t>11/08/2025</a:t>
+              <a:t>8/10/2025</a:t>
             </a:fld>
             <a:endParaRPr lang="nl-BE"/>
           </a:p>
@@ -2366,7 +2366,7 @@
           <a:p>
             <a:fld id="{5765335F-FC99-4A2B-B87B-6AF6F3762B67}" type="datetime1">
               <a:rPr lang="nl-BE" smtClean="0"/>
-              <a:t>11/08/2025</a:t>
+              <a:t>8/10/2025</a:t>
             </a:fld>
             <a:endParaRPr lang="nl-BE"/>
           </a:p>
@@ -2461,7 +2461,7 @@
           <a:p>
             <a:fld id="{1711BA58-B677-4D21-BDCD-9DD1AEA8A328}" type="datetime1">
               <a:rPr lang="nl-BE" smtClean="0"/>
-              <a:t>11/08/2025</a:t>
+              <a:t>8/10/2025</a:t>
             </a:fld>
             <a:endParaRPr lang="nl-BE"/>
           </a:p>
@@ -2738,7 +2738,7 @@
           <a:p>
             <a:fld id="{5513BE8B-B89C-461B-89D1-D5BE33ADB6B9}" type="datetime1">
               <a:rPr lang="nl-BE" smtClean="0"/>
-              <a:t>11/08/2025</a:t>
+              <a:t>8/10/2025</a:t>
             </a:fld>
             <a:endParaRPr lang="nl-BE"/>
           </a:p>
@@ -2995,7 +2995,7 @@
           <a:p>
             <a:fld id="{AEE65485-0554-4482-9B9C-289893A0B56B}" type="datetime1">
               <a:rPr lang="nl-BE" smtClean="0"/>
-              <a:t>11/08/2025</a:t>
+              <a:t>8/10/2025</a:t>
             </a:fld>
             <a:endParaRPr lang="nl-BE"/>
           </a:p>
@@ -3208,7 +3208,7 @@
           <a:p>
             <a:fld id="{6FF26CEC-AF8A-4096-9A53-521F7571A055}" type="datetime1">
               <a:rPr lang="nl-BE" smtClean="0"/>
-              <a:t>11/08/2025</a:t>
+              <a:t>8/10/2025</a:t>
             </a:fld>
             <a:endParaRPr lang="nl-BE"/>
           </a:p>
@@ -5566,7 +5566,7 @@
         </p:nvSpPr>
         <p:spPr>
           <a:xfrm>
-            <a:off x="277586" y="2320386"/>
+            <a:off x="1160813" y="2372340"/>
             <a:ext cx="2803973" cy="646331"/>
           </a:xfrm>
           <a:prstGeom prst="rect">
@@ -7735,8 +7735,8 @@
         </p:nvSpPr>
         <p:spPr>
           <a:xfrm>
-            <a:off x="628650" y="4270133"/>
-            <a:ext cx="3631122" cy="646331"/>
+            <a:off x="628650" y="3879540"/>
+            <a:ext cx="4596130" cy="646331"/>
           </a:xfrm>
           <a:prstGeom prst="rect">
             <a:avLst/>
@@ -8809,7 +8809,7 @@
         <p:spPr/>
         <p:txBody>
           <a:bodyPr>
-            <a:normAutofit lnSpcReduction="10000"/>
+            <a:normAutofit fontScale="92500" lnSpcReduction="20000"/>
           </a:bodyPr>
           <a:lstStyle/>
           <a:p>
@@ -8935,6 +8935,34 @@
                 <a:cs typeface="Courier New" panose="02070309020205020404" pitchFamily="49" charset="0"/>
               </a:rPr>
               <a:t>ubuntu:22.04</a:t>
+            </a:r>
+          </a:p>
+          <a:p>
+            <a:r>
+              <a:rPr lang="en-US" dirty="0">
+                <a:cs typeface="Courier New" panose="02070309020205020404" pitchFamily="49" charset="0"/>
+              </a:rPr>
+              <a:t>Use </a:t>
+            </a:r>
+            <a:r>
+              <a:rPr lang="en-US" dirty="0" err="1">
+                <a:latin typeface="Courier New" panose="02070309020205020404" pitchFamily="49" charset="0"/>
+                <a:cs typeface="Courier New" panose="02070309020205020404" pitchFamily="49" charset="0"/>
+              </a:rPr>
+              <a:t>apptainer</a:t>
+            </a:r>
+            <a:r>
+              <a:rPr lang="en-US" dirty="0">
+                <a:latin typeface="Courier New" panose="02070309020205020404" pitchFamily="49" charset="0"/>
+                <a:cs typeface="Courier New" panose="02070309020205020404" pitchFamily="49" charset="0"/>
+              </a:rPr>
+              <a:t> inspect</a:t>
+            </a:r>
+            <a:r>
+              <a:rPr lang="en-US" dirty="0">
+                <a:cs typeface="Courier New" panose="02070309020205020404" pitchFamily="49" charset="0"/>
+              </a:rPr>
+              <a:t> to view</a:t>
             </a:r>
           </a:p>
           <a:p>
@@ -8982,7 +9010,7 @@
         </p:nvGrpSpPr>
         <p:grpSpPr>
           <a:xfrm>
-            <a:off x="1034251" y="2807805"/>
+            <a:off x="1034251" y="2589594"/>
             <a:ext cx="6659862" cy="1402758"/>
             <a:chOff x="930727" y="4231365"/>
             <a:chExt cx="6659862" cy="1402758"/>
@@ -9412,6 +9440,55 @@
                       </p:childTnLst>
                     </p:cTn>
                   </p:par>
+                  <p:par>
+                    <p:cTn id="25" fill="hold">
+                      <p:stCondLst>
+                        <p:cond delay="indefinite"/>
+                      </p:stCondLst>
+                      <p:childTnLst>
+                        <p:par>
+                          <p:cTn id="26" fill="hold">
+                            <p:stCondLst>
+                              <p:cond delay="0"/>
+                            </p:stCondLst>
+                            <p:childTnLst>
+                              <p:par>
+                                <p:cTn id="27" presetID="1" presetClass="entr" presetSubtype="0" fill="hold" grpId="0" nodeType="clickEffect">
+                                  <p:stCondLst>
+                                    <p:cond delay="0"/>
+                                  </p:stCondLst>
+                                  <p:childTnLst>
+                                    <p:set>
+                                      <p:cBhvr>
+                                        <p:cTn id="28" dur="1" fill="hold">
+                                          <p:stCondLst>
+                                            <p:cond delay="0"/>
+                                          </p:stCondLst>
+                                        </p:cTn>
+                                        <p:tgtEl>
+                                          <p:spTgt spid="3">
+                                            <p:txEl>
+                                              <p:pRg st="10" end="10"/>
+                                            </p:txEl>
+                                          </p:spTgt>
+                                        </p:tgtEl>
+                                        <p:attrNameLst>
+                                          <p:attrName>style.visibility</p:attrName>
+                                        </p:attrNameLst>
+                                      </p:cBhvr>
+                                      <p:to>
+                                        <p:strVal val="visible"/>
+                                      </p:to>
+                                    </p:set>
+                                  </p:childTnLst>
+                                </p:cTn>
+                              </p:par>
+                            </p:childTnLst>
+                          </p:cTn>
+                        </p:par>
+                      </p:childTnLst>
+                    </p:cTn>
+                  </p:par>
                 </p:childTnLst>
               </p:cTn>
               <p:prevCondLst>
@@ -11369,33 +11446,15 @@
                                   </p:childTnLst>
                                 </p:cTn>
                               </p:par>
-                            </p:childTnLst>
-                          </p:cTn>
-                        </p:par>
-                      </p:childTnLst>
-                    </p:cTn>
-                  </p:par>
-                  <p:par>
-                    <p:cTn id="11" fill="hold">
-                      <p:stCondLst>
-                        <p:cond delay="indefinite"/>
-                      </p:stCondLst>
-                      <p:childTnLst>
-                        <p:par>
-                          <p:cTn id="12" fill="hold">
-                            <p:stCondLst>
-                              <p:cond delay="0"/>
-                            </p:stCondLst>
-                            <p:childTnLst>
                               <p:par>
-                                <p:cTn id="13" presetID="1" presetClass="entr" presetSubtype="0" fill="hold" grpId="0" nodeType="clickEffect">
+                                <p:cTn id="11" presetID="1" presetClass="entr" presetSubtype="0" fill="hold" grpId="0" nodeType="withEffect">
                                   <p:stCondLst>
                                     <p:cond delay="0"/>
                                   </p:stCondLst>
                                   <p:childTnLst>
                                     <p:set>
                                       <p:cBhvr>
-                                        <p:cTn id="14" dur="1" fill="hold">
+                                        <p:cTn id="12" dur="1" fill="hold">
                                           <p:stCondLst>
                                             <p:cond delay="0"/>
                                           </p:stCondLst>
@@ -11421,26 +11480,26 @@
                     </p:cTn>
                   </p:par>
                   <p:par>
-                    <p:cTn id="15" fill="hold">
+                    <p:cTn id="13" fill="hold">
                       <p:stCondLst>
                         <p:cond delay="indefinite"/>
                       </p:stCondLst>
                       <p:childTnLst>
                         <p:par>
-                          <p:cTn id="16" fill="hold">
+                          <p:cTn id="14" fill="hold">
                             <p:stCondLst>
                               <p:cond delay="0"/>
                             </p:stCondLst>
                             <p:childTnLst>
                               <p:par>
-                                <p:cTn id="17" presetID="1" presetClass="entr" presetSubtype="0" fill="hold" grpId="0" nodeType="clickEffect">
+                                <p:cTn id="15" presetID="1" presetClass="entr" presetSubtype="0" fill="hold" grpId="0" nodeType="clickEffect">
                                   <p:stCondLst>
                                     <p:cond delay="0"/>
                                   </p:stCondLst>
                                   <p:childTnLst>
                                     <p:set>
                                       <p:cBhvr>
-                                        <p:cTn id="18" dur="1" fill="hold">
+                                        <p:cTn id="16" dur="1" fill="hold">
                                           <p:stCondLst>
                                             <p:cond delay="0"/>
                                           </p:stCondLst>
@@ -11466,26 +11525,26 @@
                     </p:cTn>
                   </p:par>
                   <p:par>
-                    <p:cTn id="19" fill="hold">
+                    <p:cTn id="17" fill="hold">
                       <p:stCondLst>
                         <p:cond delay="indefinite"/>
                       </p:stCondLst>
                       <p:childTnLst>
                         <p:par>
-                          <p:cTn id="20" fill="hold">
+                          <p:cTn id="18" fill="hold">
                             <p:stCondLst>
                               <p:cond delay="0"/>
                             </p:stCondLst>
                             <p:childTnLst>
                               <p:par>
-                                <p:cTn id="21" presetID="1" presetClass="entr" presetSubtype="0" fill="hold" nodeType="clickEffect">
+                                <p:cTn id="19" presetID="1" presetClass="entr" presetSubtype="0" fill="hold" nodeType="clickEffect">
                                   <p:stCondLst>
                                     <p:cond delay="0"/>
                                   </p:stCondLst>
                                   <p:childTnLst>
                                     <p:set>
                                       <p:cBhvr>
-                                        <p:cTn id="22" dur="1" fill="hold">
+                                        <p:cTn id="20" dur="1" fill="hold">
                                           <p:stCondLst>
                                             <p:cond delay="0"/>
                                           </p:stCondLst>
@@ -12211,7 +12270,7 @@
           <a:p>
             <a:r>
               <a:rPr lang="en-US" dirty="0"/>
-              <a:t>Gotcha temporary directory</a:t>
+              <a:t>Gotcha: temporary directory</a:t>
             </a:r>
             <a:endParaRPr lang="LID4096" dirty="0"/>
           </a:p>
@@ -20619,30 +20678,21 @@
                             </p:childTnLst>
                           </p:cTn>
                         </p:par>
-                      </p:childTnLst>
-                    </p:cTn>
-                  </p:par>
-                  <p:par>
-                    <p:cTn id="7" fill="hold">
-                      <p:stCondLst>
-                        <p:cond delay="indefinite"/>
-                      </p:stCondLst>
-                      <p:childTnLst>
                         <p:par>
-                          <p:cTn id="8" fill="hold">
+                          <p:cTn id="7" fill="hold">
                             <p:stCondLst>
                               <p:cond delay="0"/>
                             </p:stCondLst>
                             <p:childTnLst>
                               <p:par>
-                                <p:cTn id="9" presetID="1" presetClass="entr" presetSubtype="0" fill="hold" nodeType="clickEffect">
+                                <p:cTn id="8" presetID="1" presetClass="entr" presetSubtype="0" fill="hold" nodeType="afterEffect">
                                   <p:stCondLst>
                                     <p:cond delay="0"/>
                                   </p:stCondLst>
                                   <p:childTnLst>
                                     <p:set>
                                       <p:cBhvr>
-                                        <p:cTn id="10" dur="1" fill="hold">
+                                        <p:cTn id="9" dur="1" fill="hold">
                                           <p:stCondLst>
                                             <p:cond delay="0"/>
                                           </p:stCondLst>
@@ -20668,26 +20718,26 @@
                     </p:cTn>
                   </p:par>
                   <p:par>
-                    <p:cTn id="11" fill="hold">
+                    <p:cTn id="10" fill="hold">
                       <p:stCondLst>
                         <p:cond delay="indefinite"/>
                       </p:stCondLst>
                       <p:childTnLst>
                         <p:par>
-                          <p:cTn id="12" fill="hold">
+                          <p:cTn id="11" fill="hold">
                             <p:stCondLst>
                               <p:cond delay="0"/>
                             </p:stCondLst>
                             <p:childTnLst>
                               <p:par>
-                                <p:cTn id="13" presetID="1" presetClass="entr" presetSubtype="0" fill="hold" nodeType="clickEffect">
+                                <p:cTn id="12" presetID="1" presetClass="entr" presetSubtype="0" fill="hold" nodeType="clickEffect">
                                   <p:stCondLst>
                                     <p:cond delay="0"/>
                                   </p:stCondLst>
                                   <p:childTnLst>
                                     <p:set>
                                       <p:cBhvr>
-                                        <p:cTn id="14" dur="1" fill="hold">
+                                        <p:cTn id="13" dur="1" fill="hold">
                                           <p:stCondLst>
                                             <p:cond delay="0"/>
                                           </p:stCondLst>
@@ -20713,26 +20763,26 @@
                     </p:cTn>
                   </p:par>
                   <p:par>
-                    <p:cTn id="15" fill="hold">
+                    <p:cTn id="14" fill="hold">
                       <p:stCondLst>
                         <p:cond delay="indefinite"/>
                       </p:stCondLst>
                       <p:childTnLst>
                         <p:par>
-                          <p:cTn id="16" fill="hold">
+                          <p:cTn id="15" fill="hold">
                             <p:stCondLst>
                               <p:cond delay="0"/>
                             </p:stCondLst>
                             <p:childTnLst>
                               <p:par>
-                                <p:cTn id="17" presetID="1" presetClass="entr" presetSubtype="0" fill="hold" nodeType="clickEffect">
+                                <p:cTn id="16" presetID="1" presetClass="entr" presetSubtype="0" fill="hold" nodeType="clickEffect">
                                   <p:stCondLst>
                                     <p:cond delay="0"/>
                                   </p:stCondLst>
                                   <p:childTnLst>
                                     <p:set>
                                       <p:cBhvr>
-                                        <p:cTn id="18" dur="1" fill="hold">
+                                        <p:cTn id="17" dur="1" fill="hold">
                                           <p:stCondLst>
                                             <p:cond delay="0"/>
                                           </p:stCondLst>
@@ -20758,26 +20808,26 @@
                     </p:cTn>
                   </p:par>
                   <p:par>
-                    <p:cTn id="19" fill="hold">
+                    <p:cTn id="18" fill="hold">
                       <p:stCondLst>
                         <p:cond delay="indefinite"/>
                       </p:stCondLst>
                       <p:childTnLst>
                         <p:par>
-                          <p:cTn id="20" fill="hold">
+                          <p:cTn id="19" fill="hold">
                             <p:stCondLst>
                               <p:cond delay="0"/>
                             </p:stCondLst>
                             <p:childTnLst>
                               <p:par>
-                                <p:cTn id="21" presetID="1" presetClass="entr" presetSubtype="0" fill="hold" grpId="0" nodeType="clickEffect">
+                                <p:cTn id="20" presetID="1" presetClass="entr" presetSubtype="0" fill="hold" grpId="0" nodeType="clickEffect">
                                   <p:stCondLst>
                                     <p:cond delay="0"/>
                                   </p:stCondLst>
                                   <p:childTnLst>
                                     <p:set>
                                       <p:cBhvr>
-                                        <p:cTn id="22" dur="1" fill="hold">
+                                        <p:cTn id="21" dur="1" fill="hold">
                                           <p:stCondLst>
                                             <p:cond delay="0"/>
                                           </p:stCondLst>
@@ -20800,33 +20850,15 @@
                                   </p:childTnLst>
                                 </p:cTn>
                               </p:par>
-                            </p:childTnLst>
-                          </p:cTn>
-                        </p:par>
-                      </p:childTnLst>
-                    </p:cTn>
-                  </p:par>
-                  <p:par>
-                    <p:cTn id="23" fill="hold">
-                      <p:stCondLst>
-                        <p:cond delay="indefinite"/>
-                      </p:stCondLst>
-                      <p:childTnLst>
-                        <p:par>
-                          <p:cTn id="24" fill="hold">
-                            <p:stCondLst>
-                              <p:cond delay="0"/>
-                            </p:stCondLst>
-                            <p:childTnLst>
                               <p:par>
-                                <p:cTn id="25" presetID="1" presetClass="entr" presetSubtype="0" fill="hold" grpId="0" nodeType="clickEffect">
+                                <p:cTn id="22" presetID="1" presetClass="entr" presetSubtype="0" fill="hold" grpId="0" nodeType="withEffect">
                                   <p:stCondLst>
                                     <p:cond delay="0"/>
                                   </p:stCondLst>
                                   <p:childTnLst>
                                     <p:set>
                                       <p:cBhvr>
-                                        <p:cTn id="26" dur="1" fill="hold">
+                                        <p:cTn id="23" dur="1" fill="hold">
                                           <p:stCondLst>
                                             <p:cond delay="0"/>
                                           </p:stCondLst>
@@ -21183,7 +21215,7 @@
         </p:nvSpPr>
         <p:spPr>
           <a:xfrm>
-            <a:off x="693966" y="4970160"/>
+            <a:off x="693966" y="4616866"/>
             <a:ext cx="7629012" cy="646331"/>
           </a:xfrm>
           <a:prstGeom prst="rect">
@@ -25656,6 +25688,13 @@
             <a:pPr lvl="1"/>
             <a:r>
               <a:rPr lang="en-US" dirty="0"/>
+              <a:t>MKL</a:t>
+            </a:r>
+          </a:p>
+          <a:p>
+            <a:pPr lvl="1"/>
+            <a:r>
+              <a:rPr lang="en-US" dirty="0"/>
               <a:t>MPI</a:t>
             </a:r>
           </a:p>
@@ -25724,7 +25763,7 @@
         </p:nvSpPr>
         <p:spPr>
           <a:xfrm>
-            <a:off x="2576945" y="5018808"/>
+            <a:off x="2576945" y="5455230"/>
             <a:ext cx="3793283" cy="461665"/>
           </a:xfrm>
           <a:prstGeom prst="rect">
@@ -25910,33 +25949,15 @@
                                   </p:childTnLst>
                                 </p:cTn>
                               </p:par>
-                            </p:childTnLst>
-                          </p:cTn>
-                        </p:par>
-                      </p:childTnLst>
-                    </p:cTn>
-                  </p:par>
-                  <p:par>
-                    <p:cTn id="13" fill="hold">
-                      <p:stCondLst>
-                        <p:cond delay="indefinite"/>
-                      </p:stCondLst>
-                      <p:childTnLst>
-                        <p:par>
-                          <p:cTn id="14" fill="hold">
-                            <p:stCondLst>
-                              <p:cond delay="0"/>
-                            </p:stCondLst>
-                            <p:childTnLst>
                               <p:par>
-                                <p:cTn id="15" presetID="1" presetClass="entr" presetSubtype="0" fill="hold" grpId="0" nodeType="clickEffect">
+                                <p:cTn id="13" presetID="1" presetClass="entr" presetSubtype="0" fill="hold" grpId="0" nodeType="withEffect">
                                   <p:stCondLst>
                                     <p:cond delay="0"/>
                                   </p:stCondLst>
                                   <p:childTnLst>
                                     <p:set>
                                       <p:cBhvr>
-                                        <p:cTn id="16" dur="1" fill="hold">
+                                        <p:cTn id="14" dur="1" fill="hold">
                                           <p:stCondLst>
                                             <p:cond delay="0"/>
                                           </p:stCondLst>
@@ -25945,6 +25966,55 @@
                                           <p:spTgt spid="3">
                                             <p:txEl>
                                               <p:pRg st="4" end="4"/>
+                                            </p:txEl>
+                                          </p:spTgt>
+                                        </p:tgtEl>
+                                        <p:attrNameLst>
+                                          <p:attrName>style.visibility</p:attrName>
+                                        </p:attrNameLst>
+                                      </p:cBhvr>
+                                      <p:to>
+                                        <p:strVal val="visible"/>
+                                      </p:to>
+                                    </p:set>
+                                  </p:childTnLst>
+                                </p:cTn>
+                              </p:par>
+                            </p:childTnLst>
+                          </p:cTn>
+                        </p:par>
+                      </p:childTnLst>
+                    </p:cTn>
+                  </p:par>
+                  <p:par>
+                    <p:cTn id="15" fill="hold">
+                      <p:stCondLst>
+                        <p:cond delay="indefinite"/>
+                      </p:stCondLst>
+                      <p:childTnLst>
+                        <p:par>
+                          <p:cTn id="16" fill="hold">
+                            <p:stCondLst>
+                              <p:cond delay="0"/>
+                            </p:stCondLst>
+                            <p:childTnLst>
+                              <p:par>
+                                <p:cTn id="17" presetID="1" presetClass="entr" presetSubtype="0" fill="hold" grpId="0" nodeType="clickEffect">
+                                  <p:stCondLst>
+                                    <p:cond delay="0"/>
+                                  </p:stCondLst>
+                                  <p:childTnLst>
+                                    <p:set>
+                                      <p:cBhvr>
+                                        <p:cTn id="18" dur="1" fill="hold">
+                                          <p:stCondLst>
+                                            <p:cond delay="0"/>
+                                          </p:stCondLst>
+                                        </p:cTn>
+                                        <p:tgtEl>
+                                          <p:spTgt spid="3">
+                                            <p:txEl>
+                                              <p:pRg st="5" end="5"/>
                                             </p:txEl>
                                           </p:spTgt>
                                         </p:tgtEl>
@@ -30882,6 +30952,9 @@
                     <p:cTn id="3" fill="hold">
                       <p:stCondLst>
                         <p:cond delay="indefinite"/>
+                        <p:cond evt="onBegin" delay="0">
+                          <p:tn val="2"/>
+                        </p:cond>
                       </p:stCondLst>
                       <p:childTnLst>
                         <p:par>
@@ -30891,7 +30964,7 @@
                             </p:stCondLst>
                             <p:childTnLst>
                               <p:par>
-                                <p:cTn id="5" presetID="1" presetClass="entr" presetSubtype="0" fill="hold" grpId="0" nodeType="clickEffect">
+                                <p:cTn id="5" presetID="1" presetClass="entr" presetSubtype="0" fill="hold" grpId="0" nodeType="withEffect">
                                   <p:stCondLst>
                                     <p:cond delay="0"/>
                                   </p:stCondLst>
@@ -30904,7 +30977,629 @@
                                           </p:stCondLst>
                                         </p:cTn>
                                         <p:tgtEl>
+                                          <p:spTgt spid="6">
+                                            <p:txEl>
+                                              <p:pRg st="0" end="0"/>
+                                            </p:txEl>
+                                          </p:spTgt>
+                                        </p:tgtEl>
+                                        <p:attrNameLst>
+                                          <p:attrName>style.visibility</p:attrName>
+                                        </p:attrNameLst>
+                                      </p:cBhvr>
+                                      <p:to>
+                                        <p:strVal val="visible"/>
+                                      </p:to>
+                                    </p:set>
+                                  </p:childTnLst>
+                                </p:cTn>
+                              </p:par>
+                              <p:par>
+                                <p:cTn id="7" presetID="1" presetClass="entr" presetSubtype="0" fill="hold" grpId="0" nodeType="withEffect">
+                                  <p:stCondLst>
+                                    <p:cond delay="0"/>
+                                  </p:stCondLst>
+                                  <p:childTnLst>
+                                    <p:set>
+                                      <p:cBhvr>
+                                        <p:cTn id="8" dur="1" fill="hold">
+                                          <p:stCondLst>
+                                            <p:cond delay="0"/>
+                                          </p:stCondLst>
+                                        </p:cTn>
+                                        <p:tgtEl>
+                                          <p:spTgt spid="6">
+                                            <p:txEl>
+                                              <p:pRg st="1" end="1"/>
+                                            </p:txEl>
+                                          </p:spTgt>
+                                        </p:tgtEl>
+                                        <p:attrNameLst>
+                                          <p:attrName>style.visibility</p:attrName>
+                                        </p:attrNameLst>
+                                      </p:cBhvr>
+                                      <p:to>
+                                        <p:strVal val="visible"/>
+                                      </p:to>
+                                    </p:set>
+                                  </p:childTnLst>
+                                </p:cTn>
+                              </p:par>
+                              <p:par>
+                                <p:cTn id="9" presetID="1" presetClass="entr" presetSubtype="0" fill="hold" grpId="0" nodeType="withEffect">
+                                  <p:stCondLst>
+                                    <p:cond delay="0"/>
+                                  </p:stCondLst>
+                                  <p:childTnLst>
+                                    <p:set>
+                                      <p:cBhvr>
+                                        <p:cTn id="10" dur="1" fill="hold">
+                                          <p:stCondLst>
+                                            <p:cond delay="0"/>
+                                          </p:stCondLst>
+                                        </p:cTn>
+                                        <p:tgtEl>
+                                          <p:spTgt spid="6">
+                                            <p:txEl>
+                                              <p:pRg st="2" end="2"/>
+                                            </p:txEl>
+                                          </p:spTgt>
+                                        </p:tgtEl>
+                                        <p:attrNameLst>
+                                          <p:attrName>style.visibility</p:attrName>
+                                        </p:attrNameLst>
+                                      </p:cBhvr>
+                                      <p:to>
+                                        <p:strVal val="visible"/>
+                                      </p:to>
+                                    </p:set>
+                                  </p:childTnLst>
+                                </p:cTn>
+                              </p:par>
+                            </p:childTnLst>
+                          </p:cTn>
+                        </p:par>
+                      </p:childTnLst>
+                    </p:cTn>
+                  </p:par>
+                  <p:par>
+                    <p:cTn id="11" fill="hold">
+                      <p:stCondLst>
+                        <p:cond delay="indefinite"/>
+                      </p:stCondLst>
+                      <p:childTnLst>
+                        <p:par>
+                          <p:cTn id="12" fill="hold">
+                            <p:stCondLst>
+                              <p:cond delay="0"/>
+                            </p:stCondLst>
+                            <p:childTnLst>
+                              <p:par>
+                                <p:cTn id="13" presetID="1" presetClass="entr" presetSubtype="0" fill="hold" grpId="0" nodeType="clickEffect">
+                                  <p:stCondLst>
+                                    <p:cond delay="0"/>
+                                  </p:stCondLst>
+                                  <p:childTnLst>
+                                    <p:set>
+                                      <p:cBhvr>
+                                        <p:cTn id="14" dur="1" fill="hold">
+                                          <p:stCondLst>
+                                            <p:cond delay="0"/>
+                                          </p:stCondLst>
+                                        </p:cTn>
+                                        <p:tgtEl>
+                                          <p:spTgt spid="6">
+                                            <p:txEl>
+                                              <p:pRg st="3" end="3"/>
+                                            </p:txEl>
+                                          </p:spTgt>
+                                        </p:tgtEl>
+                                        <p:attrNameLst>
+                                          <p:attrName>style.visibility</p:attrName>
+                                        </p:attrNameLst>
+                                      </p:cBhvr>
+                                      <p:to>
+                                        <p:strVal val="visible"/>
+                                      </p:to>
+                                    </p:set>
+                                  </p:childTnLst>
+                                </p:cTn>
+                              </p:par>
+                            </p:childTnLst>
+                          </p:cTn>
+                        </p:par>
+                      </p:childTnLst>
+                    </p:cTn>
+                  </p:par>
+                  <p:par>
+                    <p:cTn id="15" fill="hold">
+                      <p:stCondLst>
+                        <p:cond delay="indefinite"/>
+                      </p:stCondLst>
+                      <p:childTnLst>
+                        <p:par>
+                          <p:cTn id="16" fill="hold">
+                            <p:stCondLst>
+                              <p:cond delay="0"/>
+                            </p:stCondLst>
+                            <p:childTnLst>
+                              <p:par>
+                                <p:cTn id="17" presetID="1" presetClass="entr" presetSubtype="0" fill="hold" grpId="0" nodeType="clickEffect">
+                                  <p:stCondLst>
+                                    <p:cond delay="0"/>
+                                  </p:stCondLst>
+                                  <p:childTnLst>
+                                    <p:set>
+                                      <p:cBhvr>
+                                        <p:cTn id="18" dur="1" fill="hold">
+                                          <p:stCondLst>
+                                            <p:cond delay="0"/>
+                                          </p:stCondLst>
+                                        </p:cTn>
+                                        <p:tgtEl>
+                                          <p:spTgt spid="6">
+                                            <p:txEl>
+                                              <p:pRg st="4" end="4"/>
+                                            </p:txEl>
+                                          </p:spTgt>
+                                        </p:tgtEl>
+                                        <p:attrNameLst>
+                                          <p:attrName>style.visibility</p:attrName>
+                                        </p:attrNameLst>
+                                      </p:cBhvr>
+                                      <p:to>
+                                        <p:strVal val="visible"/>
+                                      </p:to>
+                                    </p:set>
+                                  </p:childTnLst>
+                                </p:cTn>
+                              </p:par>
+                            </p:childTnLst>
+                          </p:cTn>
+                        </p:par>
+                        <p:par>
+                          <p:cTn id="19" fill="hold">
+                            <p:stCondLst>
+                              <p:cond delay="0"/>
+                            </p:stCondLst>
+                            <p:childTnLst>
+                              <p:par>
+                                <p:cTn id="20" presetID="1" presetClass="entr" presetSubtype="0" fill="hold" grpId="0" nodeType="afterEffect">
+                                  <p:stCondLst>
+                                    <p:cond delay="0"/>
+                                  </p:stCondLst>
+                                  <p:childTnLst>
+                                    <p:set>
+                                      <p:cBhvr>
+                                        <p:cTn id="21" dur="1" fill="hold">
+                                          <p:stCondLst>
+                                            <p:cond delay="0"/>
+                                          </p:stCondLst>
+                                        </p:cTn>
+                                        <p:tgtEl>
                                           <p:spTgt spid="7"/>
+                                        </p:tgtEl>
+                                        <p:attrNameLst>
+                                          <p:attrName>style.visibility</p:attrName>
+                                        </p:attrNameLst>
+                                      </p:cBhvr>
+                                      <p:to>
+                                        <p:strVal val="visible"/>
+                                      </p:to>
+                                    </p:set>
+                                  </p:childTnLst>
+                                </p:cTn>
+                              </p:par>
+                            </p:childTnLst>
+                          </p:cTn>
+                        </p:par>
+                      </p:childTnLst>
+                    </p:cTn>
+                  </p:par>
+                  <p:par>
+                    <p:cTn id="22" fill="hold">
+                      <p:stCondLst>
+                        <p:cond delay="indefinite"/>
+                      </p:stCondLst>
+                      <p:childTnLst>
+                        <p:par>
+                          <p:cTn id="23" fill="hold">
+                            <p:stCondLst>
+                              <p:cond delay="0"/>
+                            </p:stCondLst>
+                            <p:childTnLst>
+                              <p:par>
+                                <p:cTn id="24" presetID="1" presetClass="entr" presetSubtype="0" fill="hold" grpId="0" nodeType="clickEffect">
+                                  <p:stCondLst>
+                                    <p:cond delay="0"/>
+                                  </p:stCondLst>
+                                  <p:childTnLst>
+                                    <p:set>
+                                      <p:cBhvr>
+                                        <p:cTn id="25" dur="1" fill="hold">
+                                          <p:stCondLst>
+                                            <p:cond delay="0"/>
+                                          </p:stCondLst>
+                                        </p:cTn>
+                                        <p:tgtEl>
+                                          <p:spTgt spid="6">
+                                            <p:txEl>
+                                              <p:pRg st="7" end="7"/>
+                                            </p:txEl>
+                                          </p:spTgt>
+                                        </p:tgtEl>
+                                        <p:attrNameLst>
+                                          <p:attrName>style.visibility</p:attrName>
+                                        </p:attrNameLst>
+                                      </p:cBhvr>
+                                      <p:to>
+                                        <p:strVal val="visible"/>
+                                      </p:to>
+                                    </p:set>
+                                  </p:childTnLst>
+                                </p:cTn>
+                              </p:par>
+                              <p:par>
+                                <p:cTn id="26" presetID="1" presetClass="entr" presetSubtype="0" fill="hold" grpId="0" nodeType="withEffect">
+                                  <p:stCondLst>
+                                    <p:cond delay="0"/>
+                                  </p:stCondLst>
+                                  <p:childTnLst>
+                                    <p:set>
+                                      <p:cBhvr>
+                                        <p:cTn id="27" dur="1" fill="hold">
+                                          <p:stCondLst>
+                                            <p:cond delay="0"/>
+                                          </p:stCondLst>
+                                        </p:cTn>
+                                        <p:tgtEl>
+                                          <p:spTgt spid="8"/>
+                                        </p:tgtEl>
+                                        <p:attrNameLst>
+                                          <p:attrName>style.visibility</p:attrName>
+                                        </p:attrNameLst>
+                                      </p:cBhvr>
+                                      <p:to>
+                                        <p:strVal val="visible"/>
+                                      </p:to>
+                                    </p:set>
+                                  </p:childTnLst>
+                                </p:cTn>
+                              </p:par>
+                            </p:childTnLst>
+                          </p:cTn>
+                        </p:par>
+                      </p:childTnLst>
+                    </p:cTn>
+                  </p:par>
+                  <p:par>
+                    <p:cTn id="28" fill="hold">
+                      <p:stCondLst>
+                        <p:cond delay="indefinite"/>
+                      </p:stCondLst>
+                      <p:childTnLst>
+                        <p:par>
+                          <p:cTn id="29" fill="hold">
+                            <p:stCondLst>
+                              <p:cond delay="0"/>
+                            </p:stCondLst>
+                            <p:childTnLst>
+                              <p:par>
+                                <p:cTn id="30" presetID="1" presetClass="entr" presetSubtype="0" fill="hold" nodeType="clickEffect">
+                                  <p:stCondLst>
+                                    <p:cond delay="0"/>
+                                  </p:stCondLst>
+                                  <p:childTnLst>
+                                    <p:set>
+                                      <p:cBhvr>
+                                        <p:cTn id="31" dur="1" fill="hold">
+                                          <p:stCondLst>
+                                            <p:cond delay="0"/>
+                                          </p:stCondLst>
+                                        </p:cTn>
+                                        <p:tgtEl>
+                                          <p:spTgt spid="11"/>
+                                        </p:tgtEl>
+                                        <p:attrNameLst>
+                                          <p:attrName>style.visibility</p:attrName>
+                                        </p:attrNameLst>
+                                      </p:cBhvr>
+                                      <p:to>
+                                        <p:strVal val="visible"/>
+                                      </p:to>
+                                    </p:set>
+                                  </p:childTnLst>
+                                </p:cTn>
+                              </p:par>
+                            </p:childTnLst>
+                          </p:cTn>
+                        </p:par>
+                      </p:childTnLst>
+                    </p:cTn>
+                  </p:par>
+                </p:childTnLst>
+              </p:cTn>
+              <p:prevCondLst>
+                <p:cond evt="onPrev" delay="0">
+                  <p:tgtEl>
+                    <p:sldTgt/>
+                  </p:tgtEl>
+                </p:cond>
+              </p:prevCondLst>
+              <p:nextCondLst>
+                <p:cond evt="onNext" delay="0">
+                  <p:tgtEl>
+                    <p:sldTgt/>
+                  </p:tgtEl>
+                </p:cond>
+              </p:nextCondLst>
+            </p:seq>
+          </p:childTnLst>
+        </p:cTn>
+      </p:par>
+    </p:tnLst>
+    <p:bldLst>
+      <p:bldP spid="6" grpId="0" uiExpand="1" build="p"/>
+      <p:bldP spid="7" grpId="0" animBg="1"/>
+      <p:bldP spid="8" grpId="0" animBg="1"/>
+    </p:bldLst>
+  </p:timing>
+</p:sld>
+</file>
+
+<file path=ppt/slides/slide53.xml><?xml version="1.0" encoding="utf-8"?>
+<p:sld xmlns:a="http://schemas.openxmlformats.org/drawingml/2006/main" xmlns:r="http://schemas.openxmlformats.org/officeDocument/2006/relationships" xmlns:p="http://schemas.openxmlformats.org/presentationml/2006/main">
+  <p:cSld>
+    <p:spTree>
+      <p:nvGrpSpPr>
+        <p:cNvPr id="1" name=""/>
+        <p:cNvGrpSpPr/>
+        <p:nvPr/>
+      </p:nvGrpSpPr>
+      <p:grpSpPr>
+        <a:xfrm>
+          <a:off x="0" y="0"/>
+          <a:ext cx="0" cy="0"/>
+          <a:chOff x="0" y="0"/>
+          <a:chExt cx="0" cy="0"/>
+        </a:xfrm>
+      </p:grpSpPr>
+      <p:sp>
+        <p:nvSpPr>
+          <p:cNvPr id="2" name="Title 1">
+            <a:extLst>
+              <a:ext uri="{FF2B5EF4-FFF2-40B4-BE49-F238E27FC236}">
+                <a16:creationId xmlns:a16="http://schemas.microsoft.com/office/drawing/2014/main" id="{DA8BA102-5410-4356-62AF-DF46D7CC871E}"/>
+              </a:ext>
+            </a:extLst>
+          </p:cNvPr>
+          <p:cNvSpPr>
+            <a:spLocks noGrp="1"/>
+          </p:cNvSpPr>
+          <p:nvPr>
+            <p:ph type="title"/>
+          </p:nvPr>
+        </p:nvSpPr>
+        <p:spPr/>
+        <p:txBody>
+          <a:bodyPr/>
+          <a:lstStyle/>
+          <a:p>
+            <a:r>
+              <a:rPr lang="en-US" dirty="0"/>
+              <a:t>Developing on GPUs</a:t>
+            </a:r>
+            <a:endParaRPr lang="LID4096" dirty="0"/>
+          </a:p>
+        </p:txBody>
+      </p:sp>
+      <p:sp>
+        <p:nvSpPr>
+          <p:cNvPr id="3" name="Content Placeholder 2">
+            <a:extLst>
+              <a:ext uri="{FF2B5EF4-FFF2-40B4-BE49-F238E27FC236}">
+                <a16:creationId xmlns:a16="http://schemas.microsoft.com/office/drawing/2014/main" id="{B602D71A-BD9C-F24B-A236-0A54145A95F3}"/>
+              </a:ext>
+            </a:extLst>
+          </p:cNvPr>
+          <p:cNvSpPr>
+            <a:spLocks noGrp="1"/>
+          </p:cNvSpPr>
+          <p:nvPr>
+            <p:ph idx="1"/>
+          </p:nvPr>
+        </p:nvSpPr>
+        <p:spPr/>
+        <p:txBody>
+          <a:bodyPr>
+            <a:normAutofit/>
+          </a:bodyPr>
+          <a:lstStyle/>
+          <a:p>
+            <a:r>
+              <a:rPr lang="en-US" dirty="0"/>
+              <a:t>Development libraries required</a:t>
+            </a:r>
+          </a:p>
+          <a:p>
+            <a:r>
+              <a:rPr lang="en-US" dirty="0"/>
+              <a:t>NVIDIA NGC: container catalog</a:t>
+            </a:r>
+            <a:br>
+              <a:rPr lang="en-US" dirty="0"/>
+            </a:br>
+            <a:r>
+              <a:rPr lang="en-US" sz="2400" dirty="0">
+                <a:hlinkClick r:id="rId2"/>
+              </a:rPr>
+              <a:t>https://catalog.ngc.nvidia.com/containers</a:t>
+            </a:r>
+            <a:r>
+              <a:rPr lang="en-US" sz="2400" dirty="0"/>
+              <a:t> </a:t>
+            </a:r>
+            <a:endParaRPr lang="en-US" dirty="0"/>
+          </a:p>
+          <a:p>
+            <a:pPr lvl="1"/>
+            <a:r>
+              <a:rPr lang="en-US" dirty="0"/>
+              <a:t>NVIDIA HPC SDK</a:t>
+            </a:r>
+          </a:p>
+          <a:p>
+            <a:pPr lvl="1"/>
+            <a:r>
+              <a:rPr lang="en-US" dirty="0" err="1"/>
+              <a:t>PyTorch</a:t>
+            </a:r>
+            <a:r>
+              <a:rPr lang="en-US" dirty="0"/>
+              <a:t>, </a:t>
+            </a:r>
+            <a:r>
+              <a:rPr lang="en-US" dirty="0" err="1"/>
+              <a:t>PyTorch</a:t>
+            </a:r>
+            <a:r>
+              <a:rPr lang="en-US" dirty="0"/>
+              <a:t> Lightning</a:t>
+            </a:r>
+          </a:p>
+          <a:p>
+            <a:pPr lvl="1"/>
+            <a:r>
+              <a:rPr lang="en-US" dirty="0"/>
+              <a:t>TensorFlow</a:t>
+            </a:r>
+          </a:p>
+          <a:p>
+            <a:pPr lvl="1"/>
+            <a:r>
+              <a:rPr lang="en-US" dirty="0"/>
+              <a:t>RAPIDS/RAPIDS Notebooks</a:t>
+            </a:r>
+          </a:p>
+          <a:p>
+            <a:pPr lvl="1"/>
+            <a:r>
+              <a:rPr lang="en-US" dirty="0">
+                <a:sym typeface="Symbol" panose="05050102010706020507" pitchFamily="18" charset="2"/>
+              </a:rPr>
+              <a:t></a:t>
+            </a:r>
+          </a:p>
+          <a:p>
+            <a:r>
+              <a:rPr lang="en-US" dirty="0">
+                <a:sym typeface="Symbol" panose="05050102010706020507" pitchFamily="18" charset="2"/>
+              </a:rPr>
+              <a:t>AMD Instinct</a:t>
+            </a:r>
+            <a:br>
+              <a:rPr lang="en-US" dirty="0">
+                <a:sym typeface="Symbol" panose="05050102010706020507" pitchFamily="18" charset="2"/>
+              </a:rPr>
+            </a:br>
+            <a:r>
+              <a:rPr lang="en-US" sz="2400" dirty="0">
+                <a:sym typeface="Symbol" panose="05050102010706020507" pitchFamily="18" charset="2"/>
+                <a:hlinkClick r:id="rId3"/>
+              </a:rPr>
+              <a:t>https://instinct.docs.amd.com/projects/container-toolkit/</a:t>
+            </a:r>
+            <a:r>
+              <a:rPr lang="en-US" sz="2400" dirty="0">
+                <a:sym typeface="Symbol" panose="05050102010706020507" pitchFamily="18" charset="2"/>
+              </a:rPr>
+              <a:t> </a:t>
+            </a:r>
+            <a:endParaRPr lang="LID4096" dirty="0"/>
+          </a:p>
+        </p:txBody>
+      </p:sp>
+      <p:sp>
+        <p:nvSpPr>
+          <p:cNvPr id="4" name="Slide Number Placeholder 3">
+            <a:extLst>
+              <a:ext uri="{FF2B5EF4-FFF2-40B4-BE49-F238E27FC236}">
+                <a16:creationId xmlns:a16="http://schemas.microsoft.com/office/drawing/2014/main" id="{920597EE-A522-7690-D5D4-94B343EBCCEC}"/>
+              </a:ext>
+            </a:extLst>
+          </p:cNvPr>
+          <p:cNvSpPr>
+            <a:spLocks noGrp="1"/>
+          </p:cNvSpPr>
+          <p:nvPr>
+            <p:ph type="sldNum" sz="quarter" idx="12"/>
+          </p:nvPr>
+        </p:nvSpPr>
+        <p:spPr/>
+        <p:txBody>
+          <a:bodyPr/>
+          <a:lstStyle/>
+          <a:p>
+            <a:fld id="{AEFF399F-E3B5-4890-BC79-9BC8D4DF3F2D}" type="slidenum">
+              <a:rPr lang="nl-BE" smtClean="0"/>
+              <a:t>53</a:t>
+            </a:fld>
+            <a:endParaRPr lang="nl-BE"/>
+          </a:p>
+        </p:txBody>
+      </p:sp>
+    </p:spTree>
+    <p:extLst>
+      <p:ext uri="{BB962C8B-B14F-4D97-AF65-F5344CB8AC3E}">
+        <p14:creationId xmlns:p14="http://schemas.microsoft.com/office/powerpoint/2010/main" val="4165295725"/>
+      </p:ext>
+    </p:extLst>
+  </p:cSld>
+  <p:clrMapOvr>
+    <a:masterClrMapping/>
+  </p:clrMapOvr>
+  <p:timing>
+    <p:tnLst>
+      <p:par>
+        <p:cTn id="1" dur="indefinite" restart="never" nodeType="tmRoot">
+          <p:childTnLst>
+            <p:seq concurrent="1" nextAc="seek">
+              <p:cTn id="2" dur="indefinite" nodeType="mainSeq">
+                <p:childTnLst>
+                  <p:par>
+                    <p:cTn id="3" fill="hold">
+                      <p:stCondLst>
+                        <p:cond delay="indefinite"/>
+                        <p:cond evt="onBegin" delay="0">
+                          <p:tn val="2"/>
+                        </p:cond>
+                      </p:stCondLst>
+                      <p:childTnLst>
+                        <p:par>
+                          <p:cTn id="4" fill="hold">
+                            <p:stCondLst>
+                              <p:cond delay="0"/>
+                            </p:stCondLst>
+                            <p:childTnLst>
+                              <p:par>
+                                <p:cTn id="5" presetID="1" presetClass="entr" presetSubtype="0" fill="hold" grpId="0" nodeType="afterEffect">
+                                  <p:stCondLst>
+                                    <p:cond delay="0"/>
+                                  </p:stCondLst>
+                                  <p:childTnLst>
+                                    <p:set>
+                                      <p:cBhvr>
+                                        <p:cTn id="6" dur="1" fill="hold">
+                                          <p:stCondLst>
+                                            <p:cond delay="0"/>
+                                          </p:stCondLst>
+                                        </p:cTn>
+                                        <p:tgtEl>
+                                          <p:spTgt spid="3">
+                                            <p:txEl>
+                                              <p:pRg st="0" end="0"/>
+                                            </p:txEl>
+                                          </p:spTgt>
                                         </p:tgtEl>
                                         <p:attrNameLst>
                                           <p:attrName>style.visibility</p:attrName>
@@ -30949,7 +31644,215 @@
                                           </p:stCondLst>
                                         </p:cTn>
                                         <p:tgtEl>
-                                          <p:spTgt spid="8"/>
+                                          <p:spTgt spid="3">
+                                            <p:txEl>
+                                              <p:pRg st="1" end="1"/>
+                                            </p:txEl>
+                                          </p:spTgt>
+                                        </p:tgtEl>
+                                        <p:attrNameLst>
+                                          <p:attrName>style.visibility</p:attrName>
+                                        </p:attrNameLst>
+                                      </p:cBhvr>
+                                      <p:to>
+                                        <p:strVal val="visible"/>
+                                      </p:to>
+                                    </p:set>
+                                  </p:childTnLst>
+                                </p:cTn>
+                              </p:par>
+                              <p:par>
+                                <p:cTn id="11" presetID="1" presetClass="entr" presetSubtype="0" fill="hold" grpId="0" nodeType="withEffect">
+                                  <p:stCondLst>
+                                    <p:cond delay="0"/>
+                                  </p:stCondLst>
+                                  <p:childTnLst>
+                                    <p:set>
+                                      <p:cBhvr>
+                                        <p:cTn id="12" dur="1" fill="hold">
+                                          <p:stCondLst>
+                                            <p:cond delay="0"/>
+                                          </p:stCondLst>
+                                        </p:cTn>
+                                        <p:tgtEl>
+                                          <p:spTgt spid="3">
+                                            <p:txEl>
+                                              <p:pRg st="2" end="2"/>
+                                            </p:txEl>
+                                          </p:spTgt>
+                                        </p:tgtEl>
+                                        <p:attrNameLst>
+                                          <p:attrName>style.visibility</p:attrName>
+                                        </p:attrNameLst>
+                                      </p:cBhvr>
+                                      <p:to>
+                                        <p:strVal val="visible"/>
+                                      </p:to>
+                                    </p:set>
+                                  </p:childTnLst>
+                                </p:cTn>
+                              </p:par>
+                              <p:par>
+                                <p:cTn id="13" presetID="1" presetClass="entr" presetSubtype="0" fill="hold" grpId="0" nodeType="withEffect">
+                                  <p:stCondLst>
+                                    <p:cond delay="0"/>
+                                  </p:stCondLst>
+                                  <p:childTnLst>
+                                    <p:set>
+                                      <p:cBhvr>
+                                        <p:cTn id="14" dur="1" fill="hold">
+                                          <p:stCondLst>
+                                            <p:cond delay="0"/>
+                                          </p:stCondLst>
+                                        </p:cTn>
+                                        <p:tgtEl>
+                                          <p:spTgt spid="3">
+                                            <p:txEl>
+                                              <p:pRg st="3" end="3"/>
+                                            </p:txEl>
+                                          </p:spTgt>
+                                        </p:tgtEl>
+                                        <p:attrNameLst>
+                                          <p:attrName>style.visibility</p:attrName>
+                                        </p:attrNameLst>
+                                      </p:cBhvr>
+                                      <p:to>
+                                        <p:strVal val="visible"/>
+                                      </p:to>
+                                    </p:set>
+                                  </p:childTnLst>
+                                </p:cTn>
+                              </p:par>
+                              <p:par>
+                                <p:cTn id="15" presetID="1" presetClass="entr" presetSubtype="0" fill="hold" grpId="0" nodeType="withEffect">
+                                  <p:stCondLst>
+                                    <p:cond delay="0"/>
+                                  </p:stCondLst>
+                                  <p:childTnLst>
+                                    <p:set>
+                                      <p:cBhvr>
+                                        <p:cTn id="16" dur="1" fill="hold">
+                                          <p:stCondLst>
+                                            <p:cond delay="0"/>
+                                          </p:stCondLst>
+                                        </p:cTn>
+                                        <p:tgtEl>
+                                          <p:spTgt spid="3">
+                                            <p:txEl>
+                                              <p:pRg st="4" end="4"/>
+                                            </p:txEl>
+                                          </p:spTgt>
+                                        </p:tgtEl>
+                                        <p:attrNameLst>
+                                          <p:attrName>style.visibility</p:attrName>
+                                        </p:attrNameLst>
+                                      </p:cBhvr>
+                                      <p:to>
+                                        <p:strVal val="visible"/>
+                                      </p:to>
+                                    </p:set>
+                                  </p:childTnLst>
+                                </p:cTn>
+                              </p:par>
+                              <p:par>
+                                <p:cTn id="17" presetID="1" presetClass="entr" presetSubtype="0" fill="hold" grpId="0" nodeType="withEffect">
+                                  <p:stCondLst>
+                                    <p:cond delay="0"/>
+                                  </p:stCondLst>
+                                  <p:childTnLst>
+                                    <p:set>
+                                      <p:cBhvr>
+                                        <p:cTn id="18" dur="1" fill="hold">
+                                          <p:stCondLst>
+                                            <p:cond delay="0"/>
+                                          </p:stCondLst>
+                                        </p:cTn>
+                                        <p:tgtEl>
+                                          <p:spTgt spid="3">
+                                            <p:txEl>
+                                              <p:pRg st="5" end="5"/>
+                                            </p:txEl>
+                                          </p:spTgt>
+                                        </p:tgtEl>
+                                        <p:attrNameLst>
+                                          <p:attrName>style.visibility</p:attrName>
+                                        </p:attrNameLst>
+                                      </p:cBhvr>
+                                      <p:to>
+                                        <p:strVal val="visible"/>
+                                      </p:to>
+                                    </p:set>
+                                  </p:childTnLst>
+                                </p:cTn>
+                              </p:par>
+                              <p:par>
+                                <p:cTn id="19" presetID="1" presetClass="entr" presetSubtype="0" fill="hold" grpId="0" nodeType="withEffect">
+                                  <p:stCondLst>
+                                    <p:cond delay="0"/>
+                                  </p:stCondLst>
+                                  <p:childTnLst>
+                                    <p:set>
+                                      <p:cBhvr>
+                                        <p:cTn id="20" dur="1" fill="hold">
+                                          <p:stCondLst>
+                                            <p:cond delay="0"/>
+                                          </p:stCondLst>
+                                        </p:cTn>
+                                        <p:tgtEl>
+                                          <p:spTgt spid="3">
+                                            <p:txEl>
+                                              <p:pRg st="6" end="6"/>
+                                            </p:txEl>
+                                          </p:spTgt>
+                                        </p:tgtEl>
+                                        <p:attrNameLst>
+                                          <p:attrName>style.visibility</p:attrName>
+                                        </p:attrNameLst>
+                                      </p:cBhvr>
+                                      <p:to>
+                                        <p:strVal val="visible"/>
+                                      </p:to>
+                                    </p:set>
+                                  </p:childTnLst>
+                                </p:cTn>
+                              </p:par>
+                            </p:childTnLst>
+                          </p:cTn>
+                        </p:par>
+                      </p:childTnLst>
+                    </p:cTn>
+                  </p:par>
+                  <p:par>
+                    <p:cTn id="21" fill="hold">
+                      <p:stCondLst>
+                        <p:cond delay="indefinite"/>
+                      </p:stCondLst>
+                      <p:childTnLst>
+                        <p:par>
+                          <p:cTn id="22" fill="hold">
+                            <p:stCondLst>
+                              <p:cond delay="0"/>
+                            </p:stCondLst>
+                            <p:childTnLst>
+                              <p:par>
+                                <p:cTn id="23" presetID="1" presetClass="entr" presetSubtype="0" fill="hold" grpId="0" nodeType="clickEffect">
+                                  <p:stCondLst>
+                                    <p:cond delay="0"/>
+                                  </p:stCondLst>
+                                  <p:childTnLst>
+                                    <p:set>
+                                      <p:cBhvr>
+                                        <p:cTn id="24" dur="1" fill="hold">
+                                          <p:stCondLst>
+                                            <p:cond delay="0"/>
+                                          </p:stCondLst>
+                                        </p:cTn>
+                                        <p:tgtEl>
+                                          <p:spTgt spid="3">
+                                            <p:txEl>
+                                              <p:pRg st="7" end="7"/>
+                                            </p:txEl>
+                                          </p:spTgt>
                                         </p:tgtEl>
                                         <p:attrNameLst>
                                           <p:attrName>style.visibility</p:attrName>
@@ -30990,224 +31893,9 @@
       </p:par>
     </p:tnLst>
     <p:bldLst>
-      <p:bldP spid="7" grpId="0" animBg="1"/>
-      <p:bldP spid="8" grpId="0" animBg="1"/>
+      <p:bldP spid="3" grpId="0" uiExpand="1" build="p"/>
     </p:bldLst>
   </p:timing>
-</p:sld>
-</file>
-
-<file path=ppt/slides/slide53.xml><?xml version="1.0" encoding="utf-8"?>
-<p:sld xmlns:a="http://schemas.openxmlformats.org/drawingml/2006/main" xmlns:r="http://schemas.openxmlformats.org/officeDocument/2006/relationships" xmlns:p="http://schemas.openxmlformats.org/presentationml/2006/main">
-  <p:cSld>
-    <p:spTree>
-      <p:nvGrpSpPr>
-        <p:cNvPr id="1" name=""/>
-        <p:cNvGrpSpPr/>
-        <p:nvPr/>
-      </p:nvGrpSpPr>
-      <p:grpSpPr>
-        <a:xfrm>
-          <a:off x="0" y="0"/>
-          <a:ext cx="0" cy="0"/>
-          <a:chOff x="0" y="0"/>
-          <a:chExt cx="0" cy="0"/>
-        </a:xfrm>
-      </p:grpSpPr>
-      <p:sp>
-        <p:nvSpPr>
-          <p:cNvPr id="2" name="Title 1">
-            <a:extLst>
-              <a:ext uri="{FF2B5EF4-FFF2-40B4-BE49-F238E27FC236}">
-                <a16:creationId xmlns:a16="http://schemas.microsoft.com/office/drawing/2014/main" id="{DA8BA102-5410-4356-62AF-DF46D7CC871E}"/>
-              </a:ext>
-            </a:extLst>
-          </p:cNvPr>
-          <p:cNvSpPr>
-            <a:spLocks noGrp="1"/>
-          </p:cNvSpPr>
-          <p:nvPr>
-            <p:ph type="title"/>
-          </p:nvPr>
-        </p:nvSpPr>
-        <p:spPr/>
-        <p:txBody>
-          <a:bodyPr/>
-          <a:lstStyle/>
-          <a:p>
-            <a:r>
-              <a:rPr lang="en-US" dirty="0"/>
-              <a:t>Developing on GPUs</a:t>
-            </a:r>
-            <a:endParaRPr lang="LID4096" dirty="0"/>
-          </a:p>
-        </p:txBody>
-      </p:sp>
-      <p:sp>
-        <p:nvSpPr>
-          <p:cNvPr id="3" name="Content Placeholder 2">
-            <a:extLst>
-              <a:ext uri="{FF2B5EF4-FFF2-40B4-BE49-F238E27FC236}">
-                <a16:creationId xmlns:a16="http://schemas.microsoft.com/office/drawing/2014/main" id="{B602D71A-BD9C-F24B-A236-0A54145A95F3}"/>
-              </a:ext>
-            </a:extLst>
-          </p:cNvPr>
-          <p:cNvSpPr>
-            <a:spLocks noGrp="1"/>
-          </p:cNvSpPr>
-          <p:nvPr>
-            <p:ph idx="1"/>
-          </p:nvPr>
-        </p:nvSpPr>
-        <p:spPr/>
-        <p:txBody>
-          <a:bodyPr>
-            <a:normAutofit/>
-          </a:bodyPr>
-          <a:lstStyle/>
-          <a:p>
-            <a:r>
-              <a:rPr lang="en-US" dirty="0"/>
-              <a:t>Development libraries required</a:t>
-            </a:r>
-          </a:p>
-          <a:p>
-            <a:r>
-              <a:rPr lang="en-US" dirty="0"/>
-              <a:t>NVIDIA NGC: container catalog</a:t>
-            </a:r>
-            <a:br>
-              <a:rPr lang="en-US" dirty="0"/>
-            </a:br>
-            <a:r>
-              <a:rPr lang="en-US" sz="2400" dirty="0">
-                <a:hlinkClick r:id="rId2"/>
-              </a:rPr>
-              <a:t>https://catalog.ngc.nvidia.com/containers</a:t>
-            </a:r>
-            <a:r>
-              <a:rPr lang="en-US" sz="2400" dirty="0"/>
-              <a:t> </a:t>
-            </a:r>
-            <a:endParaRPr lang="en-US" dirty="0"/>
-          </a:p>
-          <a:p>
-            <a:pPr lvl="1"/>
-            <a:r>
-              <a:rPr lang="en-US" dirty="0"/>
-              <a:t>NVIDIA HPC SDK</a:t>
-            </a:r>
-          </a:p>
-          <a:p>
-            <a:pPr lvl="1"/>
-            <a:r>
-              <a:rPr lang="en-US" dirty="0" err="1"/>
-              <a:t>PyTorch</a:t>
-            </a:r>
-            <a:r>
-              <a:rPr lang="en-US" dirty="0"/>
-              <a:t>, </a:t>
-            </a:r>
-            <a:r>
-              <a:rPr lang="en-US" dirty="0" err="1"/>
-              <a:t>PyTorch</a:t>
-            </a:r>
-            <a:r>
-              <a:rPr lang="en-US" dirty="0"/>
-              <a:t> Lightning</a:t>
-            </a:r>
-          </a:p>
-          <a:p>
-            <a:pPr lvl="1"/>
-            <a:r>
-              <a:rPr lang="en-US" dirty="0"/>
-              <a:t>TensorFlow</a:t>
-            </a:r>
-          </a:p>
-          <a:p>
-            <a:pPr lvl="1"/>
-            <a:r>
-              <a:rPr lang="en-US" dirty="0"/>
-              <a:t>RAPIDS/RAPIDS Notebooks</a:t>
-            </a:r>
-          </a:p>
-          <a:p>
-            <a:pPr lvl="1"/>
-            <a:r>
-              <a:rPr lang="en-US" dirty="0">
-                <a:sym typeface="Symbol" panose="05050102010706020507" pitchFamily="18" charset="2"/>
-              </a:rPr>
-              <a:t></a:t>
-            </a:r>
-          </a:p>
-          <a:p>
-            <a:r>
-              <a:rPr lang="en-US" dirty="0">
-                <a:sym typeface="Symbol" panose="05050102010706020507" pitchFamily="18" charset="2"/>
-              </a:rPr>
-              <a:t>AMD Instinct</a:t>
-            </a:r>
-            <a:br>
-              <a:rPr lang="en-US" dirty="0">
-                <a:sym typeface="Symbol" panose="05050102010706020507" pitchFamily="18" charset="2"/>
-              </a:rPr>
-            </a:br>
-            <a:r>
-              <a:rPr lang="en-US" sz="2400" dirty="0">
-                <a:sym typeface="Symbol" panose="05050102010706020507" pitchFamily="18" charset="2"/>
-                <a:hlinkClick r:id="rId3"/>
-              </a:rPr>
-              <a:t>https://instinct.docs.amd.com/projects/container-toolkit/</a:t>
-            </a:r>
-            <a:r>
-              <a:rPr lang="en-US" sz="2400" dirty="0">
-                <a:sym typeface="Symbol" panose="05050102010706020507" pitchFamily="18" charset="2"/>
-              </a:rPr>
-              <a:t> </a:t>
-            </a:r>
-            <a:endParaRPr lang="LID4096" dirty="0"/>
-          </a:p>
-        </p:txBody>
-      </p:sp>
-      <p:sp>
-        <p:nvSpPr>
-          <p:cNvPr id="4" name="Slide Number Placeholder 3">
-            <a:extLst>
-              <a:ext uri="{FF2B5EF4-FFF2-40B4-BE49-F238E27FC236}">
-                <a16:creationId xmlns:a16="http://schemas.microsoft.com/office/drawing/2014/main" id="{920597EE-A522-7690-D5D4-94B343EBCCEC}"/>
-              </a:ext>
-            </a:extLst>
-          </p:cNvPr>
-          <p:cNvSpPr>
-            <a:spLocks noGrp="1"/>
-          </p:cNvSpPr>
-          <p:nvPr>
-            <p:ph type="sldNum" sz="quarter" idx="12"/>
-          </p:nvPr>
-        </p:nvSpPr>
-        <p:spPr/>
-        <p:txBody>
-          <a:bodyPr/>
-          <a:lstStyle/>
-          <a:p>
-            <a:fld id="{AEFF399F-E3B5-4890-BC79-9BC8D4DF3F2D}" type="slidenum">
-              <a:rPr lang="nl-BE" smtClean="0"/>
-              <a:t>53</a:t>
-            </a:fld>
-            <a:endParaRPr lang="nl-BE"/>
-          </a:p>
-        </p:txBody>
-      </p:sp>
-    </p:spTree>
-    <p:extLst>
-      <p:ext uri="{BB962C8B-B14F-4D97-AF65-F5344CB8AC3E}">
-        <p14:creationId xmlns:p14="http://schemas.microsoft.com/office/powerpoint/2010/main" val="4165295725"/>
-      </p:ext>
-    </p:extLst>
-  </p:cSld>
-  <p:clrMapOvr>
-    <a:masterClrMapping/>
-  </p:clrMapOvr>
 </p:sld>
 </file>
 
@@ -33984,27 +34672,7 @@
                 <a:latin typeface="Courier New" panose="02070309020205020404" pitchFamily="49" charset="0"/>
                 <a:cs typeface="Courier New" panose="02070309020205020404" pitchFamily="49" charset="0"/>
               </a:rPr>
-              <a:t>  </a:t>
-            </a:r>
-            <a:r>
-              <a:rPr lang="en-US" b="1" dirty="0" err="1">
-                <a:solidFill>
-                  <a:schemeClr val="bg1"/>
-                </a:solidFill>
-                <a:latin typeface="Courier New" panose="02070309020205020404" pitchFamily="49" charset="0"/>
-                <a:cs typeface="Courier New" panose="02070309020205020404" pitchFamily="49" charset="0"/>
-              </a:rPr>
-              <a:t>instance.start</a:t>
-            </a:r>
-            <a:r>
-              <a:rPr lang="en-US" b="1" dirty="0">
-                <a:solidFill>
-                  <a:schemeClr val="bg1"/>
-                </a:solidFill>
-                <a:latin typeface="Courier New" panose="02070309020205020404" pitchFamily="49" charset="0"/>
-                <a:cs typeface="Courier New" panose="02070309020205020404" pitchFamily="49" charset="0"/>
-              </a:rPr>
-              <a:t>  \</a:t>
+              <a:t>  instance start  \</a:t>
             </a:r>
           </a:p>
           <a:p>
@@ -34157,27 +34825,7 @@
                 <a:latin typeface="Courier New" panose="02070309020205020404" pitchFamily="49" charset="0"/>
                 <a:cs typeface="Courier New" panose="02070309020205020404" pitchFamily="49" charset="0"/>
               </a:rPr>
-              <a:t>  </a:t>
-            </a:r>
-            <a:r>
-              <a:rPr lang="en-US" b="1" dirty="0" err="1">
-                <a:solidFill>
-                  <a:schemeClr val="bg1"/>
-                </a:solidFill>
-                <a:latin typeface="Courier New" panose="02070309020205020404" pitchFamily="49" charset="0"/>
-                <a:cs typeface="Courier New" panose="02070309020205020404" pitchFamily="49" charset="0"/>
-              </a:rPr>
-              <a:t>instance.stop</a:t>
-            </a:r>
-            <a:r>
-              <a:rPr lang="en-US" b="1" dirty="0">
-                <a:solidFill>
-                  <a:schemeClr val="bg1"/>
-                </a:solidFill>
-                <a:latin typeface="Courier New" panose="02070309020205020404" pitchFamily="49" charset="0"/>
-                <a:cs typeface="Courier New" panose="02070309020205020404" pitchFamily="49" charset="0"/>
-              </a:rPr>
-              <a:t>  \</a:t>
+              <a:t>  instance stop  \</a:t>
             </a:r>
           </a:p>
           <a:p>
@@ -34246,25 +34894,8 @@
                 <a:latin typeface="Courier New" panose="02070309020205020404" pitchFamily="49" charset="0"/>
                 <a:cs typeface="Courier New" panose="02070309020205020404" pitchFamily="49" charset="0"/>
               </a:rPr>
-              <a:t>  </a:t>
-            </a:r>
-            <a:r>
-              <a:rPr lang="en-US" b="1" dirty="0" err="1">
-                <a:solidFill>
-                  <a:schemeClr val="bg1"/>
-                </a:solidFill>
-                <a:latin typeface="Courier New" panose="02070309020205020404" pitchFamily="49" charset="0"/>
-                <a:cs typeface="Courier New" panose="02070309020205020404" pitchFamily="49" charset="0"/>
-              </a:rPr>
-              <a:t>instance.list</a:t>
-            </a:r>
-            <a:endParaRPr lang="en-US" b="1" dirty="0">
-              <a:solidFill>
-                <a:schemeClr val="bg1"/>
-              </a:solidFill>
-              <a:latin typeface="Courier New" panose="02070309020205020404" pitchFamily="49" charset="0"/>
-              <a:cs typeface="Courier New" panose="02070309020205020404" pitchFamily="49" charset="0"/>
-            </a:endParaRPr>
+              <a:t>  instance list</a:t>
+            </a:r>
           </a:p>
         </p:txBody>
       </p:sp>
@@ -35582,6 +36213,86 @@
                                           </p:stCondLst>
                                         </p:cTn>
                                         <p:tgtEl>
+                                          <p:spTgt spid="3">
+                                            <p:txEl>
+                                              <p:pRg st="0" end="0"/>
+                                            </p:txEl>
+                                          </p:spTgt>
+                                        </p:tgtEl>
+                                        <p:attrNameLst>
+                                          <p:attrName>style.visibility</p:attrName>
+                                        </p:attrNameLst>
+                                      </p:cBhvr>
+                                      <p:to>
+                                        <p:strVal val="visible"/>
+                                      </p:to>
+                                    </p:set>
+                                  </p:childTnLst>
+                                </p:cTn>
+                              </p:par>
+                            </p:childTnLst>
+                          </p:cTn>
+                        </p:par>
+                      </p:childTnLst>
+                    </p:cTn>
+                  </p:par>
+                  <p:par>
+                    <p:cTn id="7" fill="hold">
+                      <p:stCondLst>
+                        <p:cond delay="indefinite"/>
+                      </p:stCondLst>
+                      <p:childTnLst>
+                        <p:par>
+                          <p:cTn id="8" fill="hold">
+                            <p:stCondLst>
+                              <p:cond delay="0"/>
+                            </p:stCondLst>
+                            <p:childTnLst>
+                              <p:par>
+                                <p:cTn id="9" presetID="1" presetClass="entr" presetSubtype="0" fill="hold" grpId="0" nodeType="clickEffect">
+                                  <p:stCondLst>
+                                    <p:cond delay="0"/>
+                                  </p:stCondLst>
+                                  <p:childTnLst>
+                                    <p:set>
+                                      <p:cBhvr>
+                                        <p:cTn id="10" dur="1" fill="hold">
+                                          <p:stCondLst>
+                                            <p:cond delay="0"/>
+                                          </p:stCondLst>
+                                        </p:cTn>
+                                        <p:tgtEl>
+                                          <p:spTgt spid="3">
+                                            <p:txEl>
+                                              <p:pRg st="1" end="1"/>
+                                            </p:txEl>
+                                          </p:spTgt>
+                                        </p:tgtEl>
+                                        <p:attrNameLst>
+                                          <p:attrName>style.visibility</p:attrName>
+                                        </p:attrNameLst>
+                                      </p:cBhvr>
+                                      <p:to>
+                                        <p:strVal val="visible"/>
+                                      </p:to>
+                                    </p:set>
+                                  </p:childTnLst>
+                                </p:cTn>
+                              </p:par>
+                              <p:par>
+                                <p:cTn id="11" presetID="1" presetClass="entr" presetSubtype="0" fill="hold" grpId="0" nodeType="withEffect">
+                                  <p:stCondLst>
+                                    <p:cond delay="0"/>
+                                  </p:stCondLst>
+                                  <p:childTnLst>
+                                    <p:set>
+                                      <p:cBhvr>
+                                        <p:cTn id="12" dur="1" fill="hold">
+                                          <p:stCondLst>
+                                            <p:cond delay="0"/>
+                                          </p:stCondLst>
+                                        </p:cTn>
+                                        <p:tgtEl>
                                           <p:spTgt spid="5"/>
                                         </p:tgtEl>
                                         <p:attrNameLst>
@@ -35595,15 +36306,64 @@
                                   </p:childTnLst>
                                 </p:cTn>
                               </p:par>
+                            </p:childTnLst>
+                          </p:cTn>
+                        </p:par>
+                      </p:childTnLst>
+                    </p:cTn>
+                  </p:par>
+                  <p:par>
+                    <p:cTn id="13" fill="hold">
+                      <p:stCondLst>
+                        <p:cond delay="indefinite"/>
+                      </p:stCondLst>
+                      <p:childTnLst>
+                        <p:par>
+                          <p:cTn id="14" fill="hold">
+                            <p:stCondLst>
+                              <p:cond delay="0"/>
+                            </p:stCondLst>
+                            <p:childTnLst>
                               <p:par>
-                                <p:cTn id="7" presetID="1" presetClass="entr" presetSubtype="0" fill="hold" grpId="0" nodeType="withEffect">
+                                <p:cTn id="15" presetID="1" presetClass="entr" presetSubtype="0" fill="hold" grpId="0" nodeType="clickEffect">
                                   <p:stCondLst>
                                     <p:cond delay="0"/>
                                   </p:stCondLst>
                                   <p:childTnLst>
                                     <p:set>
                                       <p:cBhvr>
-                                        <p:cTn id="8" dur="1" fill="hold">
+                                        <p:cTn id="16" dur="1" fill="hold">
+                                          <p:stCondLst>
+                                            <p:cond delay="0"/>
+                                          </p:stCondLst>
+                                        </p:cTn>
+                                        <p:tgtEl>
+                                          <p:spTgt spid="3">
+                                            <p:txEl>
+                                              <p:pRg st="4" end="4"/>
+                                            </p:txEl>
+                                          </p:spTgt>
+                                        </p:tgtEl>
+                                        <p:attrNameLst>
+                                          <p:attrName>style.visibility</p:attrName>
+                                        </p:attrNameLst>
+                                      </p:cBhvr>
+                                      <p:to>
+                                        <p:strVal val="visible"/>
+                                      </p:to>
+                                    </p:set>
+                                  </p:childTnLst>
+                                </p:cTn>
+                              </p:par>
+                              <p:par>
+                                <p:cTn id="17" presetID="1" presetClass="entr" presetSubtype="0" fill="hold" grpId="0" nodeType="withEffect">
+                                  <p:stCondLst>
+                                    <p:cond delay="0"/>
+                                  </p:stCondLst>
+                                  <p:childTnLst>
+                                    <p:set>
+                                      <p:cBhvr>
+                                        <p:cTn id="18" dur="1" fill="hold">
                                           <p:stCondLst>
                                             <p:cond delay="0"/>
                                           </p:stCondLst>
@@ -35622,15 +36382,64 @@
                                   </p:childTnLst>
                                 </p:cTn>
                               </p:par>
+                            </p:childTnLst>
+                          </p:cTn>
+                        </p:par>
+                      </p:childTnLst>
+                    </p:cTn>
+                  </p:par>
+                  <p:par>
+                    <p:cTn id="19" fill="hold">
+                      <p:stCondLst>
+                        <p:cond delay="indefinite"/>
+                      </p:stCondLst>
+                      <p:childTnLst>
+                        <p:par>
+                          <p:cTn id="20" fill="hold">
+                            <p:stCondLst>
+                              <p:cond delay="0"/>
+                            </p:stCondLst>
+                            <p:childTnLst>
                               <p:par>
-                                <p:cTn id="9" presetID="1" presetClass="entr" presetSubtype="0" fill="hold" grpId="0" nodeType="withEffect">
+                                <p:cTn id="21" presetID="1" presetClass="entr" presetSubtype="0" fill="hold" grpId="0" nodeType="clickEffect">
                                   <p:stCondLst>
                                     <p:cond delay="0"/>
                                   </p:stCondLst>
                                   <p:childTnLst>
                                     <p:set>
                                       <p:cBhvr>
-                                        <p:cTn id="10" dur="1" fill="hold">
+                                        <p:cTn id="22" dur="1" fill="hold">
+                                          <p:stCondLst>
+                                            <p:cond delay="0"/>
+                                          </p:stCondLst>
+                                        </p:cTn>
+                                        <p:tgtEl>
+                                          <p:spTgt spid="3">
+                                            <p:txEl>
+                                              <p:pRg st="8" end="8"/>
+                                            </p:txEl>
+                                          </p:spTgt>
+                                        </p:tgtEl>
+                                        <p:attrNameLst>
+                                          <p:attrName>style.visibility</p:attrName>
+                                        </p:attrNameLst>
+                                      </p:cBhvr>
+                                      <p:to>
+                                        <p:strVal val="visible"/>
+                                      </p:to>
+                                    </p:set>
+                                  </p:childTnLst>
+                                </p:cTn>
+                              </p:par>
+                              <p:par>
+                                <p:cTn id="23" presetID="1" presetClass="entr" presetSubtype="0" fill="hold" grpId="0" nodeType="withEffect">
+                                  <p:stCondLst>
+                                    <p:cond delay="0"/>
+                                  </p:stCondLst>
+                                  <p:childTnLst>
+                                    <p:set>
+                                      <p:cBhvr>
+                                        <p:cTn id="24" dur="1" fill="hold">
                                           <p:stCondLst>
                                             <p:cond delay="0"/>
                                           </p:stCondLst>
@@ -35677,6 +36486,7 @@
       </p:par>
     </p:tnLst>
     <p:bldLst>
+      <p:bldP spid="3" grpId="0" uiExpand="1" build="p"/>
       <p:bldP spid="5" grpId="0" animBg="1"/>
       <p:bldP spid="6" grpId="0" animBg="1"/>
       <p:bldP spid="7" grpId="0" animBg="1"/>
@@ -41973,6 +42783,13 @@
             </a:r>
           </a:p>
           <a:p>
+            <a:pPr lvl="1"/>
+            <a:r>
+              <a:rPr lang="en-US" dirty="0"/>
+              <a:t>Reproducibility</a:t>
+            </a:r>
+          </a:p>
+          <a:p>
             <a:r>
               <a:rPr lang="en-US" dirty="0"/>
               <a:t>The bad: containers pose security risks</a:t>
@@ -42003,7 +42820,7 @@
         </p:nvSpPr>
         <p:spPr>
           <a:xfrm>
-            <a:off x="2767695" y="5404757"/>
+            <a:off x="5116041" y="5311239"/>
             <a:ext cx="2455800" cy="523220"/>
           </a:xfrm>
           <a:prstGeom prst="rect">
@@ -42455,6 +43272,55 @@
                                     <p:set>
                                       <p:cBhvr>
                                         <p:cTn id="34" dur="1" fill="hold">
+                                          <p:stCondLst>
+                                            <p:cond delay="0"/>
+                                          </p:stCondLst>
+                                        </p:cTn>
+                                        <p:tgtEl>
+                                          <p:spTgt spid="3">
+                                            <p:txEl>
+                                              <p:pRg st="8" end="8"/>
+                                            </p:txEl>
+                                          </p:spTgt>
+                                        </p:tgtEl>
+                                        <p:attrNameLst>
+                                          <p:attrName>style.visibility</p:attrName>
+                                        </p:attrNameLst>
+                                      </p:cBhvr>
+                                      <p:to>
+                                        <p:strVal val="visible"/>
+                                      </p:to>
+                                    </p:set>
+                                  </p:childTnLst>
+                                </p:cTn>
+                              </p:par>
+                            </p:childTnLst>
+                          </p:cTn>
+                        </p:par>
+                      </p:childTnLst>
+                    </p:cTn>
+                  </p:par>
+                  <p:par>
+                    <p:cTn id="35" fill="hold">
+                      <p:stCondLst>
+                        <p:cond delay="indefinite"/>
+                      </p:stCondLst>
+                      <p:childTnLst>
+                        <p:par>
+                          <p:cTn id="36" fill="hold">
+                            <p:stCondLst>
+                              <p:cond delay="0"/>
+                            </p:stCondLst>
+                            <p:childTnLst>
+                              <p:par>
+                                <p:cTn id="37" presetID="1" presetClass="entr" presetSubtype="0" fill="hold" grpId="0" nodeType="clickEffect">
+                                  <p:stCondLst>
+                                    <p:cond delay="0"/>
+                                  </p:stCondLst>
+                                  <p:childTnLst>
+                                    <p:set>
+                                      <p:cBhvr>
+                                        <p:cTn id="38" dur="1" fill="hold">
                                           <p:stCondLst>
                                             <p:cond delay="0"/>
                                           </p:stCondLst>

</xml_diff>

<commit_message>
Add links to hpccm primitives and building block docs
</commit_message>
<xml_diff>
--- a/containers_for_hpc.pptx
+++ b/containers_for_hpc.pptx
@@ -402,7 +402,7 @@
           <a:p>
             <a:fld id="{6BD974B4-F374-4E74-84D3-1EB7DBF32A2A}" type="datetimeFigureOut">
               <a:rPr lang="nl-BE" smtClean="0"/>
-              <a:t>8/10/2025</a:t>
+              <a:t>11/02/2026</a:t>
             </a:fld>
             <a:endParaRPr lang="nl-BE"/>
           </a:p>
@@ -885,7 +885,7 @@
           <a:p>
             <a:fld id="{A433E747-842D-4EF3-8202-AC54FEC33061}" type="datetime1">
               <a:rPr lang="nl-BE" smtClean="0"/>
-              <a:t>8/10/2025</a:t>
+              <a:t>11/02/2026</a:t>
             </a:fld>
             <a:endParaRPr lang="nl-BE"/>
           </a:p>
@@ -1055,7 +1055,7 @@
           <a:p>
             <a:fld id="{7C821354-3381-4DF5-ABED-FDAFA2BAD3F8}" type="datetime1">
               <a:rPr lang="nl-BE" smtClean="0"/>
-              <a:t>8/10/2025</a:t>
+              <a:t>11/02/2026</a:t>
             </a:fld>
             <a:endParaRPr lang="nl-BE"/>
           </a:p>
@@ -1235,7 +1235,7 @@
           <a:p>
             <a:fld id="{C6B54B95-9964-4BBF-B171-A69413AB9FC5}" type="datetime1">
               <a:rPr lang="nl-BE" smtClean="0"/>
-              <a:t>8/10/2025</a:t>
+              <a:t>11/02/2026</a:t>
             </a:fld>
             <a:endParaRPr lang="nl-BE"/>
           </a:p>
@@ -1405,7 +1405,7 @@
           <a:p>
             <a:fld id="{BE45CDE5-064C-4862-90E9-83B8FD778625}" type="datetime1">
               <a:rPr lang="nl-BE" smtClean="0"/>
-              <a:t>8/10/2025</a:t>
+              <a:t>11/02/2026</a:t>
             </a:fld>
             <a:endParaRPr lang="nl-BE"/>
           </a:p>
@@ -1649,7 +1649,7 @@
           <a:p>
             <a:fld id="{C75A345C-628E-463E-B8F7-69C25D344DF5}" type="datetime1">
               <a:rPr lang="nl-BE" smtClean="0"/>
-              <a:t>8/10/2025</a:t>
+              <a:t>11/02/2026</a:t>
             </a:fld>
             <a:endParaRPr lang="nl-BE"/>
           </a:p>
@@ -1881,7 +1881,7 @@
           <a:p>
             <a:fld id="{65B04534-538C-4249-A635-8BB2B8486464}" type="datetime1">
               <a:rPr lang="nl-BE" smtClean="0"/>
-              <a:t>8/10/2025</a:t>
+              <a:t>11/02/2026</a:t>
             </a:fld>
             <a:endParaRPr lang="nl-BE"/>
           </a:p>
@@ -2248,7 +2248,7 @@
           <a:p>
             <a:fld id="{089671CB-8547-4C91-A3D5-012E6E8790E6}" type="datetime1">
               <a:rPr lang="nl-BE" smtClean="0"/>
-              <a:t>8/10/2025</a:t>
+              <a:t>11/02/2026</a:t>
             </a:fld>
             <a:endParaRPr lang="nl-BE"/>
           </a:p>
@@ -2366,7 +2366,7 @@
           <a:p>
             <a:fld id="{5765335F-FC99-4A2B-B87B-6AF6F3762B67}" type="datetime1">
               <a:rPr lang="nl-BE" smtClean="0"/>
-              <a:t>8/10/2025</a:t>
+              <a:t>11/02/2026</a:t>
             </a:fld>
             <a:endParaRPr lang="nl-BE"/>
           </a:p>
@@ -2461,7 +2461,7 @@
           <a:p>
             <a:fld id="{1711BA58-B677-4D21-BDCD-9DD1AEA8A328}" type="datetime1">
               <a:rPr lang="nl-BE" smtClean="0"/>
-              <a:t>8/10/2025</a:t>
+              <a:t>11/02/2026</a:t>
             </a:fld>
             <a:endParaRPr lang="nl-BE"/>
           </a:p>
@@ -2738,7 +2738,7 @@
           <a:p>
             <a:fld id="{5513BE8B-B89C-461B-89D1-D5BE33ADB6B9}" type="datetime1">
               <a:rPr lang="nl-BE" smtClean="0"/>
-              <a:t>8/10/2025</a:t>
+              <a:t>11/02/2026</a:t>
             </a:fld>
             <a:endParaRPr lang="nl-BE"/>
           </a:p>
@@ -2995,7 +2995,7 @@
           <a:p>
             <a:fld id="{AEE65485-0554-4482-9B9C-289893A0B56B}" type="datetime1">
               <a:rPr lang="nl-BE" smtClean="0"/>
-              <a:t>8/10/2025</a:t>
+              <a:t>11/02/2026</a:t>
             </a:fld>
             <a:endParaRPr lang="nl-BE"/>
           </a:p>
@@ -3208,7 +3208,7 @@
           <a:p>
             <a:fld id="{6FF26CEC-AF8A-4096-9A53-521F7571A055}" type="datetime1">
               <a:rPr lang="nl-BE" smtClean="0"/>
-              <a:t>8/10/2025</a:t>
+              <a:t>11/02/2026</a:t>
             </a:fld>
             <a:endParaRPr lang="nl-BE"/>
           </a:p>
@@ -41566,7 +41566,7 @@
         <p:spPr/>
         <p:txBody>
           <a:bodyPr>
-            <a:normAutofit fontScale="92500" lnSpcReduction="20000"/>
+            <a:normAutofit fontScale="62500" lnSpcReduction="20000"/>
           </a:bodyPr>
           <a:lstStyle/>
           <a:p>
@@ -41650,33 +41650,79 @@
           </a:p>
           <a:p>
             <a:r>
-              <a:rPr lang="en-US" dirty="0" err="1">
-                <a:hlinkClick r:id="rId5"/>
-              </a:rPr>
-              <a:t>HPCWired</a:t>
-            </a:r>
-            <a:r>
-              <a:rPr lang="en-US" dirty="0">
-                <a:hlinkClick r:id="rId5"/>
-              </a:rPr>
-              <a:t> article</a:t>
+              <a:rPr lang="en-US" dirty="0" err="1"/>
+              <a:t>hpccm</a:t>
             </a:r>
             <a:r>
               <a:rPr lang="en-US" dirty="0"/>
-              <a:t> discussing singularity versus Docker/Shifter</a:t>
-            </a:r>
-          </a:p>
-          <a:p>
-            <a:r>
-              <a:rPr lang="en-US" dirty="0"/>
-              <a:t>DVC (Data Version Control)</a:t>
+              <a:t> primitives</a:t>
             </a:r>
             <a:br>
               <a:rPr lang="en-US" dirty="0"/>
             </a:br>
             <a:r>
+              <a:rPr lang="en-US" sz="2600" dirty="0">
+                <a:hlinkClick r:id="rId5"/>
+              </a:rPr>
+              <a:t>https://github.com/NVIDIA/hpc-container-maker/blob/master/docs/primitives.md</a:t>
+            </a:r>
+            <a:endParaRPr lang="en-US" dirty="0"/>
+          </a:p>
+          <a:p>
+            <a:r>
+              <a:rPr lang="en-US" dirty="0" err="1"/>
+              <a:t>hpccm</a:t>
+            </a:r>
+            <a:r>
+              <a:rPr lang="en-US" dirty="0"/>
+              <a:t> building block (software packages)</a:t>
+            </a:r>
+            <a:br>
+              <a:rPr lang="en-US" dirty="0"/>
+            </a:br>
+            <a:r>
+              <a:rPr lang="en-US" sz="2600" dirty="0">
+                <a:hlinkClick r:id="rId6"/>
+              </a:rPr>
+              <a:t>https://github.com/NVIDIA/hpc-container-maker/blob/master/docs/building_blocks.md</a:t>
+            </a:r>
+            <a:r>
+              <a:rPr lang="en-US" dirty="0"/>
+              <a:t> </a:t>
+            </a:r>
+            <a:endParaRPr lang="en-US" dirty="0">
+              <a:hlinkClick r:id="rId7"/>
+            </a:endParaRPr>
+          </a:p>
+          <a:p>
+            <a:r>
+              <a:rPr lang="en-US" dirty="0" err="1">
+                <a:hlinkClick r:id="rId7"/>
+              </a:rPr>
+              <a:t>HPCWired</a:t>
+            </a:r>
+            <a:r>
               <a:rPr lang="en-US" dirty="0">
-                <a:hlinkClick r:id="rId6"/>
+                <a:hlinkClick r:id="rId7"/>
+              </a:rPr>
+              <a:t> article</a:t>
+            </a:r>
+            <a:r>
+              <a:rPr lang="en-US" dirty="0"/>
+              <a:t> discussing singularity versus Docker/Shifter</a:t>
+            </a:r>
+          </a:p>
+          <a:p>
+            <a:r>
+              <a:rPr lang="en-US" dirty="0"/>
+              <a:t>DVC (Data Version Control)</a:t>
+            </a:r>
+            <a:br>
+              <a:rPr lang="en-US" dirty="0"/>
+            </a:br>
+            <a:r>
+              <a:rPr lang="en-US" dirty="0">
+                <a:hlinkClick r:id="rId8"/>
               </a:rPr>
               <a:t>https://dvc.org/</a:t>
             </a:r>

</xml_diff>